<commit_message>
Save earlier presentation package and source-figure updates
</commit_message>
<xml_diff>
--- a/two/Thesis_Presentation_Final_Package/Thesis_Presentation_Final/Thesis_Presentation_Final.pptx
+++ b/two/Thesis_Presentation_Final_Package/Thesis_Presentation_Final/Thesis_Presentation_Final.pptx
@@ -4277,8 +4277,8 @@
         </p:blipFill>
         <p:spPr>
           <a:xfrm>
-            <a:off x="411480" y="1143000"/>
-            <a:ext cx="3474720" cy="2629518"/>
+            <a:off x="411480" y="1270761"/>
+            <a:ext cx="3474719" cy="2373995"/>
           </a:xfrm>
           <a:prstGeom prst="rect">
             <a:avLst/>
@@ -4301,8 +4301,8 @@
         </p:blipFill>
         <p:spPr>
           <a:xfrm>
-            <a:off x="4069080" y="1143000"/>
-            <a:ext cx="3520440" cy="2806837"/>
+            <a:off x="4069081" y="1456027"/>
+            <a:ext cx="3520438" cy="2180782"/>
           </a:xfrm>
           <a:prstGeom prst="rect">
             <a:avLst/>
@@ -4325,8 +4325,8 @@
         </p:blipFill>
         <p:spPr>
           <a:xfrm>
-            <a:off x="7772400" y="1143000"/>
-            <a:ext cx="3474720" cy="2629518"/>
+            <a:off x="7772401" y="1386561"/>
+            <a:ext cx="3474718" cy="2142395"/>
           </a:xfrm>
           <a:prstGeom prst="rect">
             <a:avLst/>
@@ -4472,7 +4472,7 @@
               </a:defRPr>
             </a:pPr>
             <a:r>
-              <a:t>Case A: contact-induced rotation occurred towards the configured surface for both tested initial rotational directions.</a:t>
+              <a:t>Case A: contact-induced rotation occurred towards the configured surface for both tested rotational directions.</a:t>
             </a:r>
           </a:p>
           <a:p>
@@ -4798,8 +4798,8 @@
         </p:blipFill>
         <p:spPr>
           <a:xfrm>
-            <a:off x="685800" y="1051560"/>
-            <a:ext cx="6035040" cy="5657850"/>
+            <a:off x="685800" y="1830119"/>
+            <a:ext cx="6035039" cy="4100732"/>
           </a:xfrm>
           <a:prstGeom prst="rect">
             <a:avLst/>
@@ -4815,7 +4815,7 @@
         <p:spPr>
           <a:xfrm>
             <a:off x="7086600" y="1097280"/>
-            <a:ext cx="3657600" cy="4480560"/>
+            <a:ext cx="3657600" cy="4892040"/>
           </a:xfrm>
           <a:prstGeom prst="roundRect">
             <a:avLst/>
@@ -4895,7 +4895,7 @@
         <p:spPr>
           <a:xfrm>
             <a:off x="7333488" y="1737360"/>
-            <a:ext cx="3063240" cy="3474720"/>
+            <a:ext cx="3063240" cy="3977639"/>
           </a:xfrm>
           <a:prstGeom prst="rect">
             <a:avLst/>
@@ -7566,7 +7566,7 @@
               </a:defRPr>
             </a:pPr>
             <a:r>
-              <a:t>Implement an adaptive CoC strategy: start at the TCP, estimate the initial angular offset, temporarily select the supporting tangential displacement, then return the CoC to the TCP after alignment.</a:t>
+              <a:t>Implement an adaptive CoC strategy: start at the TCP, estimate the angular offset, temporarily select the supporting tangential displacement, then return the CoC to the TCP after alignment.</a:t>
             </a:r>
           </a:p>
           <a:p>
@@ -12427,22 +12427,22 @@
       </p:sp>
       <p:pic>
         <p:nvPicPr>
-          <p:cNvPr id="23" name="Picture 22" descr="fig_4_1_experimental_system.png"/>
+          <p:cNvPr id="23" name="Picture 22" descr="fig_4_2_measured_angles.png"/>
           <p:cNvPicPr>
             <a:picLocks noChangeAspect="1"/>
           </p:cNvPicPr>
           <p:nvPr/>
         </p:nvPicPr>
         <p:blipFill>
-          <a:blip r:embed="rId3"/>
+          <a:blip r:embed="rId4"/>
           <a:stretch>
             <a:fillRect/>
           </a:stretch>
         </p:blipFill>
         <p:spPr>
           <a:xfrm>
-            <a:off x="685800" y="2331720"/>
-            <a:ext cx="5303520" cy="2370157"/>
+            <a:off x="502921" y="2580740"/>
+            <a:ext cx="5650990" cy="2281736"/>
           </a:xfrm>
           <a:prstGeom prst="rect">
             <a:avLst/>
@@ -12563,7 +12563,7 @@
               </a:defRPr>
             </a:pPr>
             <a:r>
-              <a:t>Case A — CoC at TCP, positive/negative/zero offset.</a:t>
+              <a:t>Case A — CoC at TCP; three measured entry offsets.</a:t>
             </a:r>
           </a:p>
           <a:p>
@@ -12611,7 +12611,7 @@
               </a:defRPr>
             </a:pPr>
             <a:r>
-              <a:t>Case D — tangential CoC position for both initial offset directions.</a:t>
+              <a:t>Case D — tangential CoC position for both angular-offset directions.</a:t>
             </a:r>
           </a:p>
           <a:p>
@@ -12628,6 +12628,57 @@
             </a:pPr>
             <a:r>
               <a:t>Three repetitions per parameter setting.</a:t>
+            </a:r>
+          </a:p>
+        </p:txBody>
+      </p:sp>
+      <p:sp>
+        <p:nvSpPr>
+          <p:cNvPr id="27" name="Measured angle references"/>
+          <p:cNvSpPr txBox="1"/>
+          <p:nvPr/>
+        </p:nvSpPr>
+        <p:spPr>
+          <a:xfrm>
+            <a:off x="658368" y="5532120"/>
+            <a:ext cx="10652760" cy="676656"/>
+          </a:xfrm>
+          <a:prstGeom prst="rect">
+            <a:avLst/>
+          </a:prstGeom>
+          <a:noFill/>
+        </p:spPr>
+        <p:txBody>
+          <a:bodyPr wrap="none" lIns="0">
+            <a:spAutoFit/>
+          </a:bodyPr>
+          <a:lstStyle/>
+          <a:p>
+            <a:pPr marL="0" indent="0">
+              <a:buNone/>
+            </a:pPr>
+            <a:r>
+              <a:rPr sz="1400">
+                <a:solidFill>
+                  <a:srgbClr val="606060"/>
+                </a:solidFill>
+                <a:latin typeface="Aptos"/>
+              </a:rPr>
+              <a:t>Measured entry offset: configured reference → contact entry.</a:t>
+            </a:r>
+          </a:p>
+          <a:p>
+            <a:pPr marL="0" indent="0">
+              <a:buNone/>
+            </a:pPr>
+            <a:r>
+              <a:rPr sz="1400">
+                <a:solidFill>
+                  <a:srgbClr val="606060"/>
+                </a:solidFill>
+                <a:latin typeface="Aptos"/>
+              </a:rPr>
+              <a:t>Contact response: contact end → entry, opposite to the end-effector rotation during contact.</a:t>
             </a:r>
           </a:p>
         </p:txBody>

</xml_diff>